<commit_message>
Fix PPTX layout for placeholders and editable Mermaid flowcharts
Place diagrams and tables inside content and picture placeholders so
two-column and picture-caption layouts align correctly. Render a subset
of Mermaid flowcharts as native PowerPoint shapes for in-deck editing,
falling back to PNG when unsupported. Regenerate output/weekly-report.pptx.

Co-authored-by: 18682922316 <18682922316@users.noreply.github.com>
</commit_message>
<xml_diff>
--- a/output/weekly-report.pptx
+++ b/output/weekly-report.pptx
@@ -3110,12 +3110,7 @@
           <a:lstStyle/>
           <a:p>
             <a:r>
-              <a:rPr b="1">
-                <a:solidFill>
-                  <a:srgbClr val="1F4E79"/>
-                </a:solidFill>
-                <a:latin typeface="Source Han Sans CN"/>
-              </a:rPr>
+              <a:rPr b="1"/>
               <a:t>Efficient Sparse Attention for Long-Context LLMs</a:t>
             </a:r>
           </a:p>
@@ -3137,9 +3132,6 @@
           <a:lstStyle/>
           <a:p>
             <a:r>
-              <a:rPr>
-                <a:latin typeface="Source Han Sans CN"/>
-              </a:rPr>
               <a:t>Author Name · Affiliation · 2026</a:t>
             </a:r>
           </a:p>
@@ -3179,12 +3171,7 @@
           <a:lstStyle/>
           <a:p>
             <a:r>
-              <a:rPr b="1">
-                <a:solidFill>
-                  <a:srgbClr val="1F4E79"/>
-                </a:solidFill>
-                <a:latin typeface="Source Han Sans CN"/>
-              </a:rPr>
+              <a:rPr b="1"/>
               <a:t>Background</a:t>
             </a:r>
           </a:p>
@@ -3207,27 +3194,18 @@
           <a:p>
             <a:pPr/>
             <a:r>
-              <a:rPr>
-                <a:latin typeface="Source Han Sans CN"/>
-              </a:rPr>
               <a:t>长上下文场景对注意力机制提出新挑战</a:t>
             </a:r>
           </a:p>
           <a:p>
             <a:pPr/>
             <a:r>
-              <a:rPr>
-                <a:latin typeface="Source Han Sans CN"/>
-              </a:rPr>
               <a:t>全注意力计算复杂度 \(O(n^2)\)，显存压力显著</a:t>
             </a:r>
           </a:p>
           <a:p>
             <a:pPr/>
             <a:r>
-              <a:rPr>
-                <a:latin typeface="Source Han Sans CN"/>
-              </a:rPr>
               <a:t>现有稀疏方法在精度与效率间难以兼顾</a:t>
             </a:r>
           </a:p>
@@ -3267,12 +3245,7 @@
           <a:lstStyle/>
           <a:p>
             <a:r>
-              <a:rPr b="1">
-                <a:solidFill>
-                  <a:srgbClr val="1F4E79"/>
-                </a:solidFill>
-                <a:latin typeface="Source Han Sans CN"/>
-              </a:rPr>
+              <a:rPr b="1"/>
               <a:t>Method Overview</a:t>
             </a:r>
           </a:p>
@@ -3293,37 +3266,26 @@
           <a:bodyPr/>
           <a:lstStyle/>
           <a:p>
-            <a:r>
-              <a:rPr>
-                <a:latin typeface="Source Han Sans CN"/>
-              </a:rPr>
+            <a:pPr/>
+            <a:r>
               <a:t>我们提出一种基于动态路由的稀疏注意力（DRSA）：</a:t>
             </a:r>
           </a:p>
           <a:p>
             <a:pPr/>
             <a:r>
-              <a:rPr>
-                <a:latin typeface="Source Han Sans CN"/>
-              </a:rPr>
               <a:t>在每个解码步动态选择 Top-k 关键 token</a:t>
             </a:r>
           </a:p>
           <a:p>
             <a:pPr/>
             <a:r>
-              <a:rPr>
-                <a:latin typeface="Source Han Sans CN"/>
-              </a:rPr>
               <a:t>通过低秩近似估计 token 重要性</a:t>
             </a:r>
           </a:p>
           <a:p>
             <a:pPr/>
             <a:r>
-              <a:rPr>
-                <a:latin typeface="Source Han Sans CN"/>
-              </a:rPr>
               <a:t>与 KV-Cache 压缩协同优化</a:t>
             </a:r>
           </a:p>
@@ -3346,30 +3308,284 @@
           <a:p/>
         </p:txBody>
       </p:sp>
-      <p:pic>
-        <p:nvPicPr>
-          <p:cNvPr id="5" name="Picture 4" descr="mermaid-6703018555d3.png"/>
-          <p:cNvPicPr>
-            <a:picLocks noChangeAspect="1"/>
-          </p:cNvPicPr>
+      <p:sp>
+        <p:nvSpPr>
+          <p:cNvPr id="5" name="Rectangle 4"/>
+          <p:cNvSpPr/>
           <p:nvPr/>
-        </p:nvPicPr>
-        <p:blipFill>
-          <a:blip r:embed="rId2"/>
-          <a:stretch>
-            <a:fillRect/>
-          </a:stretch>
-        </p:blipFill>
+        </p:nvSpPr>
         <p:spPr>
           <a:xfrm>
-            <a:off x="4754880" y="1463040"/>
-            <a:ext cx="3931920" cy="935915"/>
+            <a:off x="4648200" y="1600200"/>
+            <a:ext cx="4038600" cy="4525963"/>
           </a:xfrm>
           <a:prstGeom prst="rect">
             <a:avLst/>
           </a:prstGeom>
+          <a:solidFill>
+            <a:srgbClr val="FFFFFF"/>
+          </a:solidFill>
+          <a:ln>
+            <a:noFill/>
+          </a:ln>
         </p:spPr>
-      </p:pic>
+        <p:style>
+          <a:lnRef idx="1">
+            <a:schemeClr val="accent1"/>
+          </a:lnRef>
+          <a:fillRef idx="3">
+            <a:schemeClr val="accent1"/>
+          </a:fillRef>
+          <a:effectRef idx="2">
+            <a:schemeClr val="accent1"/>
+          </a:effectRef>
+          <a:fontRef idx="minor">
+            <a:schemeClr val="lt1"/>
+          </a:fontRef>
+        </p:style>
+        <p:txBody>
+          <a:bodyPr rtlCol="0" anchor="ctr"/>
+          <a:lstStyle/>
+          <a:p>
+            <a:pPr algn="ctr"/>
+          </a:p>
+        </p:txBody>
+      </p:sp>
+      <p:cxnSp>
+        <p:nvCxnSpPr>
+          <p:cNvPr id="6" name="Connector 5"/>
+          <p:cNvCxnSpPr/>
+          <p:nvPr/>
+        </p:nvCxnSpPr>
+        <p:spPr>
+          <a:xfrm>
+            <a:off x="5874857" y="3863181"/>
+            <a:ext cx="346782" cy="0"/>
+          </a:xfrm>
+          <a:prstGeom prst="line">
+            <a:avLst/>
+          </a:prstGeom>
+          <a:ln w="12700">
+            <a:solidFill>
+              <a:srgbClr val="555555"/>
+            </a:solidFill>
+          </a:ln>
+        </p:spPr>
+        <p:style>
+          <a:lnRef idx="2">
+            <a:schemeClr val="accent1"/>
+          </a:lnRef>
+          <a:fillRef idx="0">
+            <a:schemeClr val="accent1"/>
+          </a:fillRef>
+          <a:effectRef idx="1">
+            <a:schemeClr val="accent1"/>
+          </a:effectRef>
+          <a:fontRef idx="minor">
+            <a:schemeClr val="tx1"/>
+          </a:fontRef>
+        </p:style>
+      </p:cxnSp>
+      <p:cxnSp>
+        <p:nvCxnSpPr>
+          <p:cNvPr id="7" name="Connector 6"/>
+          <p:cNvCxnSpPr/>
+          <p:nvPr/>
+        </p:nvCxnSpPr>
+        <p:spPr>
+          <a:xfrm>
+            <a:off x="7113361" y="3863181"/>
+            <a:ext cx="346782" cy="0"/>
+          </a:xfrm>
+          <a:prstGeom prst="line">
+            <a:avLst/>
+          </a:prstGeom>
+          <a:ln w="12700">
+            <a:solidFill>
+              <a:srgbClr val="555555"/>
+            </a:solidFill>
+          </a:ln>
+        </p:spPr>
+        <p:style>
+          <a:lnRef idx="2">
+            <a:schemeClr val="accent1"/>
+          </a:lnRef>
+          <a:fillRef idx="0">
+            <a:schemeClr val="accent1"/>
+          </a:fillRef>
+          <a:effectRef idx="1">
+            <a:schemeClr val="accent1"/>
+          </a:effectRef>
+          <a:fontRef idx="minor">
+            <a:schemeClr val="tx1"/>
+          </a:fontRef>
+        </p:style>
+      </p:cxnSp>
+      <p:sp>
+        <p:nvSpPr>
+          <p:cNvPr id="8" name="Rounded Rectangle 7"/>
+          <p:cNvSpPr/>
+          <p:nvPr/>
+        </p:nvSpPr>
+        <p:spPr>
+          <a:xfrm>
+            <a:off x="4983135" y="2867469"/>
+            <a:ext cx="891722" cy="1991424"/>
+          </a:xfrm>
+          <a:prstGeom prst="roundRect">
+            <a:avLst/>
+          </a:prstGeom>
+          <a:solidFill>
+            <a:srgbClr val="F2F6FC"/>
+          </a:solidFill>
+          <a:ln w="12700">
+            <a:solidFill>
+              <a:srgbClr val="2F5599"/>
+            </a:solidFill>
+          </a:ln>
+        </p:spPr>
+        <p:style>
+          <a:lnRef idx="1">
+            <a:schemeClr val="accent1"/>
+          </a:lnRef>
+          <a:fillRef idx="3">
+            <a:schemeClr val="accent1"/>
+          </a:fillRef>
+          <a:effectRef idx="2">
+            <a:schemeClr val="accent1"/>
+          </a:effectRef>
+          <a:fontRef idx="minor">
+            <a:schemeClr val="lt1"/>
+          </a:fontRef>
+        </p:style>
+        <p:txBody>
+          <a:bodyPr rtlCol="0" anchor="ctr" lIns="50000" rIns="50000" tIns="50000" bIns="50000" wrap="square">
+            <a:noAutofit/>
+          </a:bodyPr>
+          <a:lstStyle/>
+          <a:p>
+            <a:pPr algn="ctr"/>
+            <a:r>
+              <a:rPr sz="1000" b="1">
+                <a:solidFill>
+                  <a:srgbClr val="202020"/>
+                </a:solidFill>
+              </a:rPr>
+              <a:t>Top-k 路由</a:t>
+            </a:r>
+          </a:p>
+        </p:txBody>
+      </p:sp>
+      <p:sp>
+        <p:nvSpPr>
+          <p:cNvPr id="9" name="Rounded Rectangle 8"/>
+          <p:cNvSpPr/>
+          <p:nvPr/>
+        </p:nvSpPr>
+        <p:spPr>
+          <a:xfrm>
+            <a:off x="6221639" y="2867469"/>
+            <a:ext cx="891722" cy="1991424"/>
+          </a:xfrm>
+          <a:prstGeom prst="roundRect">
+            <a:avLst/>
+          </a:prstGeom>
+          <a:solidFill>
+            <a:srgbClr val="F2F6FC"/>
+          </a:solidFill>
+          <a:ln w="12700">
+            <a:solidFill>
+              <a:srgbClr val="2F5599"/>
+            </a:solidFill>
+          </a:ln>
+        </p:spPr>
+        <p:style>
+          <a:lnRef idx="1">
+            <a:schemeClr val="accent1"/>
+          </a:lnRef>
+          <a:fillRef idx="3">
+            <a:schemeClr val="accent1"/>
+          </a:fillRef>
+          <a:effectRef idx="2">
+            <a:schemeClr val="accent1"/>
+          </a:effectRef>
+          <a:fontRef idx="minor">
+            <a:schemeClr val="lt1"/>
+          </a:fontRef>
+        </p:style>
+        <p:txBody>
+          <a:bodyPr rtlCol="0" anchor="ctr" lIns="50000" rIns="50000" tIns="50000" bIns="50000" wrap="square">
+            <a:noAutofit/>
+          </a:bodyPr>
+          <a:lstStyle/>
+          <a:p>
+            <a:pPr algn="ctr"/>
+            <a:r>
+              <a:rPr sz="1000" b="1">
+                <a:solidFill>
+                  <a:srgbClr val="202020"/>
+                </a:solidFill>
+              </a:rPr>
+              <a:t>低秩估计</a:t>
+            </a:r>
+          </a:p>
+        </p:txBody>
+      </p:sp>
+      <p:sp>
+        <p:nvSpPr>
+          <p:cNvPr id="10" name="Rounded Rectangle 9"/>
+          <p:cNvSpPr/>
+          <p:nvPr/>
+        </p:nvSpPr>
+        <p:spPr>
+          <a:xfrm>
+            <a:off x="7460143" y="2867469"/>
+            <a:ext cx="891722" cy="1991424"/>
+          </a:xfrm>
+          <a:prstGeom prst="roundRect">
+            <a:avLst/>
+          </a:prstGeom>
+          <a:solidFill>
+            <a:srgbClr val="F2F6FC"/>
+          </a:solidFill>
+          <a:ln w="12700">
+            <a:solidFill>
+              <a:srgbClr val="2F5599"/>
+            </a:solidFill>
+          </a:ln>
+        </p:spPr>
+        <p:style>
+          <a:lnRef idx="1">
+            <a:schemeClr val="accent1"/>
+          </a:lnRef>
+          <a:fillRef idx="3">
+            <a:schemeClr val="accent1"/>
+          </a:fillRef>
+          <a:effectRef idx="2">
+            <a:schemeClr val="accent1"/>
+          </a:effectRef>
+          <a:fontRef idx="minor">
+            <a:schemeClr val="lt1"/>
+          </a:fontRef>
+        </p:style>
+        <p:txBody>
+          <a:bodyPr rtlCol="0" anchor="ctr" lIns="50000" rIns="50000" tIns="50000" bIns="50000" wrap="square">
+            <a:noAutofit/>
+          </a:bodyPr>
+          <a:lstStyle/>
+          <a:p>
+            <a:pPr algn="ctr"/>
+            <a:r>
+              <a:rPr sz="1000" b="1">
+                <a:solidFill>
+                  <a:srgbClr val="202020"/>
+                </a:solidFill>
+              </a:rPr>
+              <a:t>KV 协同</a:t>
+            </a:r>
+          </a:p>
+        </p:txBody>
+      </p:sp>
     </p:spTree>
   </p:cSld>
   <p:clrMapOvr>
@@ -3404,12 +3620,7 @@
           <a:lstStyle/>
           <a:p>
             <a:r>
-              <a:rPr b="1">
-                <a:solidFill>
-                  <a:srgbClr val="1F4E79"/>
-                </a:solidFill>
-                <a:latin typeface="Source Han Sans CN"/>
-              </a:rPr>
+              <a:rPr b="1"/>
               <a:t>Architecture</a:t>
             </a:r>
           </a:p>
@@ -3444,30 +3655,374 @@
           <a:p/>
         </p:txBody>
       </p:sp>
-      <p:pic>
-        <p:nvPicPr>
-          <p:cNvPr id="5" name="Picture 4" descr="mermaid-4d547d85e293.png"/>
-          <p:cNvPicPr>
-            <a:picLocks noChangeAspect="1"/>
-          </p:cNvPicPr>
+      <p:sp>
+        <p:nvSpPr>
+          <p:cNvPr id="5" name="Rectangle 4"/>
+          <p:cNvSpPr/>
           <p:nvPr/>
-        </p:nvPicPr>
-        <p:blipFill>
-          <a:blip r:embed="rId2"/>
-          <a:stretch>
-            <a:fillRect/>
-          </a:stretch>
-        </p:blipFill>
+        </p:nvSpPr>
         <p:spPr>
           <a:xfrm>
-            <a:off x="457200" y="1463040"/>
-            <a:ext cx="2393044" cy="4937760"/>
+            <a:off x="1792288" y="612775"/>
+            <a:ext cx="5486400" cy="4114800"/>
           </a:xfrm>
           <a:prstGeom prst="rect">
             <a:avLst/>
           </a:prstGeom>
+          <a:solidFill>
+            <a:srgbClr val="FFFFFF"/>
+          </a:solidFill>
+          <a:ln>
+            <a:noFill/>
+          </a:ln>
         </p:spPr>
-      </p:pic>
+        <p:style>
+          <a:lnRef idx="1">
+            <a:schemeClr val="accent1"/>
+          </a:lnRef>
+          <a:fillRef idx="3">
+            <a:schemeClr val="accent1"/>
+          </a:fillRef>
+          <a:effectRef idx="2">
+            <a:schemeClr val="accent1"/>
+          </a:effectRef>
+          <a:fontRef idx="minor">
+            <a:schemeClr val="lt1"/>
+          </a:fontRef>
+        </p:style>
+        <p:txBody>
+          <a:bodyPr rtlCol="0" anchor="ctr"/>
+          <a:lstStyle/>
+          <a:p>
+            <a:pPr algn="ctr"/>
+          </a:p>
+        </p:txBody>
+      </p:sp>
+      <p:cxnSp>
+        <p:nvCxnSpPr>
+          <p:cNvPr id="6" name="Connector 5"/>
+          <p:cNvCxnSpPr/>
+          <p:nvPr/>
+        </p:nvCxnSpPr>
+        <p:spPr>
+          <a:xfrm>
+            <a:off x="3096953" y="2670175"/>
+            <a:ext cx="353325" cy="0"/>
+          </a:xfrm>
+          <a:prstGeom prst="line">
+            <a:avLst/>
+          </a:prstGeom>
+          <a:ln w="12700">
+            <a:solidFill>
+              <a:srgbClr val="555555"/>
+            </a:solidFill>
+          </a:ln>
+        </p:spPr>
+        <p:style>
+          <a:lnRef idx="2">
+            <a:schemeClr val="accent1"/>
+          </a:lnRef>
+          <a:fillRef idx="0">
+            <a:schemeClr val="accent1"/>
+          </a:fillRef>
+          <a:effectRef idx="1">
+            <a:schemeClr val="accent1"/>
+          </a:effectRef>
+          <a:fontRef idx="minor">
+            <a:schemeClr val="tx1"/>
+          </a:fontRef>
+        </p:style>
+      </p:cxnSp>
+      <p:cxnSp>
+        <p:nvCxnSpPr>
+          <p:cNvPr id="7" name="Connector 6"/>
+          <p:cNvCxnSpPr/>
+          <p:nvPr/>
+        </p:nvCxnSpPr>
+        <p:spPr>
+          <a:xfrm>
+            <a:off x="4358825" y="2670175"/>
+            <a:ext cx="353325" cy="0"/>
+          </a:xfrm>
+          <a:prstGeom prst="line">
+            <a:avLst/>
+          </a:prstGeom>
+          <a:ln w="12700">
+            <a:solidFill>
+              <a:srgbClr val="555555"/>
+            </a:solidFill>
+          </a:ln>
+        </p:spPr>
+        <p:style>
+          <a:lnRef idx="2">
+            <a:schemeClr val="accent1"/>
+          </a:lnRef>
+          <a:fillRef idx="0">
+            <a:schemeClr val="accent1"/>
+          </a:fillRef>
+          <a:effectRef idx="1">
+            <a:schemeClr val="accent1"/>
+          </a:effectRef>
+          <a:fontRef idx="minor">
+            <a:schemeClr val="tx1"/>
+          </a:fontRef>
+        </p:style>
+      </p:cxnSp>
+      <p:cxnSp>
+        <p:nvCxnSpPr>
+          <p:cNvPr id="8" name="Connector 7"/>
+          <p:cNvCxnSpPr/>
+          <p:nvPr/>
+        </p:nvCxnSpPr>
+        <p:spPr>
+          <a:xfrm>
+            <a:off x="5620697" y="2670175"/>
+            <a:ext cx="353325" cy="0"/>
+          </a:xfrm>
+          <a:prstGeom prst="line">
+            <a:avLst/>
+          </a:prstGeom>
+          <a:ln w="12700">
+            <a:solidFill>
+              <a:srgbClr val="555555"/>
+            </a:solidFill>
+          </a:ln>
+        </p:spPr>
+        <p:style>
+          <a:lnRef idx="2">
+            <a:schemeClr val="accent1"/>
+          </a:lnRef>
+          <a:fillRef idx="0">
+            <a:schemeClr val="accent1"/>
+          </a:fillRef>
+          <a:effectRef idx="1">
+            <a:schemeClr val="accent1"/>
+          </a:effectRef>
+          <a:fontRef idx="minor">
+            <a:schemeClr val="tx1"/>
+          </a:fontRef>
+        </p:style>
+      </p:cxnSp>
+      <p:sp>
+        <p:nvSpPr>
+          <p:cNvPr id="9" name="Rounded Rectangle 8"/>
+          <p:cNvSpPr/>
+          <p:nvPr/>
+        </p:nvSpPr>
+        <p:spPr>
+          <a:xfrm>
+            <a:off x="2188406" y="1764919"/>
+            <a:ext cx="908547" cy="1810512"/>
+          </a:xfrm>
+          <a:prstGeom prst="roundRect">
+            <a:avLst/>
+          </a:prstGeom>
+          <a:solidFill>
+            <a:srgbClr val="F2F6FC"/>
+          </a:solidFill>
+          <a:ln w="12700">
+            <a:solidFill>
+              <a:srgbClr val="2F5599"/>
+            </a:solidFill>
+          </a:ln>
+        </p:spPr>
+        <p:style>
+          <a:lnRef idx="1">
+            <a:schemeClr val="accent1"/>
+          </a:lnRef>
+          <a:fillRef idx="3">
+            <a:schemeClr val="accent1"/>
+          </a:fillRef>
+          <a:effectRef idx="2">
+            <a:schemeClr val="accent1"/>
+          </a:effectRef>
+          <a:fontRef idx="minor">
+            <a:schemeClr val="lt1"/>
+          </a:fontRef>
+        </p:style>
+        <p:txBody>
+          <a:bodyPr rtlCol="0" anchor="ctr" lIns="50000" rIns="50000" tIns="50000" bIns="50000" wrap="square">
+            <a:noAutofit/>
+          </a:bodyPr>
+          <a:lstStyle/>
+          <a:p>
+            <a:pPr algn="ctr"/>
+            <a:r>
+              <a:rPr sz="1000" b="1">
+                <a:solidFill>
+                  <a:srgbClr val="202020"/>
+                </a:solidFill>
+              </a:rPr>
+              <a:t>Token序列</a:t>
+            </a:r>
+          </a:p>
+        </p:txBody>
+      </p:sp>
+      <p:sp>
+        <p:nvSpPr>
+          <p:cNvPr id="10" name="Rounded Rectangle 9"/>
+          <p:cNvSpPr/>
+          <p:nvPr/>
+        </p:nvSpPr>
+        <p:spPr>
+          <a:xfrm>
+            <a:off x="3450278" y="1764919"/>
+            <a:ext cx="908547" cy="1810512"/>
+          </a:xfrm>
+          <a:prstGeom prst="roundRect">
+            <a:avLst/>
+          </a:prstGeom>
+          <a:solidFill>
+            <a:srgbClr val="F2F6FC"/>
+          </a:solidFill>
+          <a:ln w="12700">
+            <a:solidFill>
+              <a:srgbClr val="2F5599"/>
+            </a:solidFill>
+          </a:ln>
+        </p:spPr>
+        <p:style>
+          <a:lnRef idx="1">
+            <a:schemeClr val="accent1"/>
+          </a:lnRef>
+          <a:fillRef idx="3">
+            <a:schemeClr val="accent1"/>
+          </a:fillRef>
+          <a:effectRef idx="2">
+            <a:schemeClr val="accent1"/>
+          </a:effectRef>
+          <a:fontRef idx="minor">
+            <a:schemeClr val="lt1"/>
+          </a:fontRef>
+        </p:style>
+        <p:txBody>
+          <a:bodyPr rtlCol="0" anchor="ctr" lIns="50000" rIns="50000" tIns="50000" bIns="50000" wrap="square">
+            <a:noAutofit/>
+          </a:bodyPr>
+          <a:lstStyle/>
+          <a:p>
+            <a:pPr algn="ctr"/>
+            <a:r>
+              <a:rPr sz="1000" b="1">
+                <a:solidFill>
+                  <a:srgbClr val="202020"/>
+                </a:solidFill>
+              </a:rPr>
+              <a:t>动态路由</a:t>
+            </a:r>
+          </a:p>
+        </p:txBody>
+      </p:sp>
+      <p:sp>
+        <p:nvSpPr>
+          <p:cNvPr id="11" name="Rounded Rectangle 10"/>
+          <p:cNvSpPr/>
+          <p:nvPr/>
+        </p:nvSpPr>
+        <p:spPr>
+          <a:xfrm>
+            <a:off x="4712150" y="1764919"/>
+            <a:ext cx="908547" cy="1810512"/>
+          </a:xfrm>
+          <a:prstGeom prst="roundRect">
+            <a:avLst/>
+          </a:prstGeom>
+          <a:solidFill>
+            <a:srgbClr val="F2F6FC"/>
+          </a:solidFill>
+          <a:ln w="12700">
+            <a:solidFill>
+              <a:srgbClr val="2F5599"/>
+            </a:solidFill>
+          </a:ln>
+        </p:spPr>
+        <p:style>
+          <a:lnRef idx="1">
+            <a:schemeClr val="accent1"/>
+          </a:lnRef>
+          <a:fillRef idx="3">
+            <a:schemeClr val="accent1"/>
+          </a:fillRef>
+          <a:effectRef idx="2">
+            <a:schemeClr val="accent1"/>
+          </a:effectRef>
+          <a:fontRef idx="minor">
+            <a:schemeClr val="lt1"/>
+          </a:fontRef>
+        </p:style>
+        <p:txBody>
+          <a:bodyPr rtlCol="0" anchor="ctr" lIns="50000" rIns="50000" tIns="50000" bIns="50000" wrap="square">
+            <a:noAutofit/>
+          </a:bodyPr>
+          <a:lstStyle/>
+          <a:p>
+            <a:pPr algn="ctr"/>
+            <a:r>
+              <a:rPr sz="1000" b="1">
+                <a:solidFill>
+                  <a:srgbClr val="202020"/>
+                </a:solidFill>
+              </a:rPr>
+              <a:t>稀疏注意力</a:t>
+            </a:r>
+          </a:p>
+        </p:txBody>
+      </p:sp>
+      <p:sp>
+        <p:nvSpPr>
+          <p:cNvPr id="12" name="Rounded Rectangle 11"/>
+          <p:cNvSpPr/>
+          <p:nvPr/>
+        </p:nvSpPr>
+        <p:spPr>
+          <a:xfrm>
+            <a:off x="5974022" y="1764919"/>
+            <a:ext cx="908547" cy="1810512"/>
+          </a:xfrm>
+          <a:prstGeom prst="roundRect">
+            <a:avLst/>
+          </a:prstGeom>
+          <a:solidFill>
+            <a:srgbClr val="F2F6FC"/>
+          </a:solidFill>
+          <a:ln w="12700">
+            <a:solidFill>
+              <a:srgbClr val="2F5599"/>
+            </a:solidFill>
+          </a:ln>
+        </p:spPr>
+        <p:style>
+          <a:lnRef idx="1">
+            <a:schemeClr val="accent1"/>
+          </a:lnRef>
+          <a:fillRef idx="3">
+            <a:schemeClr val="accent1"/>
+          </a:fillRef>
+          <a:effectRef idx="2">
+            <a:schemeClr val="accent1"/>
+          </a:effectRef>
+          <a:fontRef idx="minor">
+            <a:schemeClr val="lt1"/>
+          </a:fontRef>
+        </p:style>
+        <p:txBody>
+          <a:bodyPr rtlCol="0" anchor="ctr" lIns="50000" rIns="50000" tIns="50000" bIns="50000" wrap="square">
+            <a:noAutofit/>
+          </a:bodyPr>
+          <a:lstStyle/>
+          <a:p>
+            <a:pPr algn="ctr"/>
+            <a:r>
+              <a:rPr sz="1000" b="1">
+                <a:solidFill>
+                  <a:srgbClr val="202020"/>
+                </a:solidFill>
+              </a:rPr>
+              <a:t>上下文输出</a:t>
+            </a:r>
+          </a:p>
+        </p:txBody>
+      </p:sp>
     </p:spTree>
   </p:cSld>
   <p:clrMapOvr>
@@ -3502,12 +4057,7 @@
           <a:lstStyle/>
           <a:p>
             <a:r>
-              <a:rPr b="1">
-                <a:solidFill>
-                  <a:srgbClr val="1F4E79"/>
-                </a:solidFill>
-                <a:latin typeface="Source Han Sans CN"/>
-              </a:rPr>
+              <a:rPr b="1"/>
               <a:t>Experimental Setup</a:t>
             </a:r>
           </a:p>
@@ -3530,36 +4080,24 @@
           <a:p>
             <a:pPr/>
             <a:r>
-              <a:rPr>
-                <a:latin typeface="Source Han Sans CN"/>
-              </a:rPr>
               <a:t>**Datasets**: PG-19, LongBench, ZeroSCROLLS</a:t>
             </a:r>
           </a:p>
           <a:p>
             <a:pPr/>
             <a:r>
-              <a:rPr>
-                <a:latin typeface="Source Han Sans CN"/>
-              </a:rPr>
               <a:t>**Backbones**: LLaMA-2-7B, Mistral-7B</a:t>
             </a:r>
           </a:p>
           <a:p>
             <a:pPr/>
             <a:r>
-              <a:rPr>
-                <a:latin typeface="Source Han Sans CN"/>
-              </a:rPr>
               <a:t>**Baselines**: Full Attention, Longformer, BigBird, StreamingLLM</a:t>
             </a:r>
           </a:p>
           <a:p>
             <a:pPr/>
             <a:r>
-              <a:rPr>
-                <a:latin typeface="Source Han Sans CN"/>
-              </a:rPr>
               <a:t>**Hardware**: 8 × A100 80GB</a:t>
             </a:r>
           </a:p>
@@ -3599,12 +4137,7 @@
           <a:lstStyle/>
           <a:p>
             <a:r>
-              <a:rPr b="1">
-                <a:solidFill>
-                  <a:srgbClr val="1F4E79"/>
-                </a:solidFill>
-                <a:latin typeface="Source Han Sans CN"/>
-              </a:rPr>
+              <a:rPr b="1"/>
               <a:t>Results</a:t>
             </a:r>
           </a:p>
@@ -3636,7 +4169,7 @@
           <p:nvPr/>
         </p:nvGraphicFramePr>
         <p:xfrm>
-          <a:off x="457200" y="1463040"/>
+          <a:off x="457200" y="1600200"/>
           <a:ext cx="8229600" cy="2194560"/>
         </p:xfrm>
         <a:graphic>
@@ -3993,12 +4526,7 @@
           <a:lstStyle/>
           <a:p>
             <a:r>
-              <a:rPr b="1">
-                <a:solidFill>
-                  <a:srgbClr val="1F4E79"/>
-                </a:solidFill>
-                <a:latin typeface="Source Han Sans CN"/>
-              </a:rPr>
+              <a:rPr b="1"/>
               <a:t>Conclusion</a:t>
             </a:r>
           </a:p>
@@ -4021,27 +4549,18 @@
           <a:p>
             <a:pPr/>
             <a:r>
-              <a:rPr>
-                <a:latin typeface="Source Han Sans CN"/>
-              </a:rPr>
               <a:t>DRSA 在 5 个长文本任务上同时改善精度与效率</a:t>
             </a:r>
           </a:p>
           <a:p>
             <a:pPr/>
             <a:r>
-              <a:rPr>
-                <a:latin typeface="Source Han Sans CN"/>
-              </a:rPr>
               <a:t>与现有 KV-Cache 优化方法正交，可叠加使用</a:t>
             </a:r>
           </a:p>
           <a:p>
             <a:pPr/>
             <a:r>
-              <a:rPr>
-                <a:latin typeface="Source Han Sans CN"/>
-              </a:rPr>
               <a:t>代码与权重将开源于 GitHub</a:t>
             </a:r>
           </a:p>

</xml_diff>

<commit_message>
Fix PPTX layout for placeholders and editable Mermaid flowcharts (#7)
Place diagrams and tables inside content and picture placeholders so
two-column and picture-caption layouts align correctly. Render a subset
of Mermaid flowcharts as native PowerPoint shapes for in-deck editing,
falling back to PNG when unsupported. Regenerate output/weekly-report.pptx.

Co-authored-by: Cursor Agent <cursoragent@cursor.com>
Co-authored-by: 18682922316 <18682922316@users.noreply.github.com>
</commit_message>
<xml_diff>
--- a/output/weekly-report.pptx
+++ b/output/weekly-report.pptx
@@ -3110,12 +3110,7 @@
           <a:lstStyle/>
           <a:p>
             <a:r>
-              <a:rPr b="1">
-                <a:solidFill>
-                  <a:srgbClr val="1F4E79"/>
-                </a:solidFill>
-                <a:latin typeface="Source Han Sans CN"/>
-              </a:rPr>
+              <a:rPr b="1"/>
               <a:t>Efficient Sparse Attention for Long-Context LLMs</a:t>
             </a:r>
           </a:p>
@@ -3137,9 +3132,6 @@
           <a:lstStyle/>
           <a:p>
             <a:r>
-              <a:rPr>
-                <a:latin typeface="Source Han Sans CN"/>
-              </a:rPr>
               <a:t>Author Name · Affiliation · 2026</a:t>
             </a:r>
           </a:p>
@@ -3179,12 +3171,7 @@
           <a:lstStyle/>
           <a:p>
             <a:r>
-              <a:rPr b="1">
-                <a:solidFill>
-                  <a:srgbClr val="1F4E79"/>
-                </a:solidFill>
-                <a:latin typeface="Source Han Sans CN"/>
-              </a:rPr>
+              <a:rPr b="1"/>
               <a:t>Background</a:t>
             </a:r>
           </a:p>
@@ -3207,27 +3194,18 @@
           <a:p>
             <a:pPr/>
             <a:r>
-              <a:rPr>
-                <a:latin typeface="Source Han Sans CN"/>
-              </a:rPr>
               <a:t>长上下文场景对注意力机制提出新挑战</a:t>
             </a:r>
           </a:p>
           <a:p>
             <a:pPr/>
             <a:r>
-              <a:rPr>
-                <a:latin typeface="Source Han Sans CN"/>
-              </a:rPr>
               <a:t>全注意力计算复杂度 \(O(n^2)\)，显存压力显著</a:t>
             </a:r>
           </a:p>
           <a:p>
             <a:pPr/>
             <a:r>
-              <a:rPr>
-                <a:latin typeface="Source Han Sans CN"/>
-              </a:rPr>
               <a:t>现有稀疏方法在精度与效率间难以兼顾</a:t>
             </a:r>
           </a:p>
@@ -3267,12 +3245,7 @@
           <a:lstStyle/>
           <a:p>
             <a:r>
-              <a:rPr b="1">
-                <a:solidFill>
-                  <a:srgbClr val="1F4E79"/>
-                </a:solidFill>
-                <a:latin typeface="Source Han Sans CN"/>
-              </a:rPr>
+              <a:rPr b="1"/>
               <a:t>Method Overview</a:t>
             </a:r>
           </a:p>
@@ -3293,37 +3266,26 @@
           <a:bodyPr/>
           <a:lstStyle/>
           <a:p>
-            <a:r>
-              <a:rPr>
-                <a:latin typeface="Source Han Sans CN"/>
-              </a:rPr>
+            <a:pPr/>
+            <a:r>
               <a:t>我们提出一种基于动态路由的稀疏注意力（DRSA）：</a:t>
             </a:r>
           </a:p>
           <a:p>
             <a:pPr/>
             <a:r>
-              <a:rPr>
-                <a:latin typeface="Source Han Sans CN"/>
-              </a:rPr>
               <a:t>在每个解码步动态选择 Top-k 关键 token</a:t>
             </a:r>
           </a:p>
           <a:p>
             <a:pPr/>
             <a:r>
-              <a:rPr>
-                <a:latin typeface="Source Han Sans CN"/>
-              </a:rPr>
               <a:t>通过低秩近似估计 token 重要性</a:t>
             </a:r>
           </a:p>
           <a:p>
             <a:pPr/>
             <a:r>
-              <a:rPr>
-                <a:latin typeface="Source Han Sans CN"/>
-              </a:rPr>
               <a:t>与 KV-Cache 压缩协同优化</a:t>
             </a:r>
           </a:p>
@@ -3346,30 +3308,284 @@
           <a:p/>
         </p:txBody>
       </p:sp>
-      <p:pic>
-        <p:nvPicPr>
-          <p:cNvPr id="5" name="Picture 4" descr="mermaid-6703018555d3.png"/>
-          <p:cNvPicPr>
-            <a:picLocks noChangeAspect="1"/>
-          </p:cNvPicPr>
+      <p:sp>
+        <p:nvSpPr>
+          <p:cNvPr id="5" name="Rectangle 4"/>
+          <p:cNvSpPr/>
           <p:nvPr/>
-        </p:nvPicPr>
-        <p:blipFill>
-          <a:blip r:embed="rId2"/>
-          <a:stretch>
-            <a:fillRect/>
-          </a:stretch>
-        </p:blipFill>
+        </p:nvSpPr>
         <p:spPr>
           <a:xfrm>
-            <a:off x="4754880" y="1463040"/>
-            <a:ext cx="3931920" cy="935915"/>
+            <a:off x="4648200" y="1600200"/>
+            <a:ext cx="4038600" cy="4525963"/>
           </a:xfrm>
           <a:prstGeom prst="rect">
             <a:avLst/>
           </a:prstGeom>
+          <a:solidFill>
+            <a:srgbClr val="FFFFFF"/>
+          </a:solidFill>
+          <a:ln>
+            <a:noFill/>
+          </a:ln>
         </p:spPr>
-      </p:pic>
+        <p:style>
+          <a:lnRef idx="1">
+            <a:schemeClr val="accent1"/>
+          </a:lnRef>
+          <a:fillRef idx="3">
+            <a:schemeClr val="accent1"/>
+          </a:fillRef>
+          <a:effectRef idx="2">
+            <a:schemeClr val="accent1"/>
+          </a:effectRef>
+          <a:fontRef idx="minor">
+            <a:schemeClr val="lt1"/>
+          </a:fontRef>
+        </p:style>
+        <p:txBody>
+          <a:bodyPr rtlCol="0" anchor="ctr"/>
+          <a:lstStyle/>
+          <a:p>
+            <a:pPr algn="ctr"/>
+          </a:p>
+        </p:txBody>
+      </p:sp>
+      <p:cxnSp>
+        <p:nvCxnSpPr>
+          <p:cNvPr id="6" name="Connector 5"/>
+          <p:cNvCxnSpPr/>
+          <p:nvPr/>
+        </p:nvCxnSpPr>
+        <p:spPr>
+          <a:xfrm>
+            <a:off x="5874857" y="3863181"/>
+            <a:ext cx="346782" cy="0"/>
+          </a:xfrm>
+          <a:prstGeom prst="line">
+            <a:avLst/>
+          </a:prstGeom>
+          <a:ln w="12700">
+            <a:solidFill>
+              <a:srgbClr val="555555"/>
+            </a:solidFill>
+          </a:ln>
+        </p:spPr>
+        <p:style>
+          <a:lnRef idx="2">
+            <a:schemeClr val="accent1"/>
+          </a:lnRef>
+          <a:fillRef idx="0">
+            <a:schemeClr val="accent1"/>
+          </a:fillRef>
+          <a:effectRef idx="1">
+            <a:schemeClr val="accent1"/>
+          </a:effectRef>
+          <a:fontRef idx="minor">
+            <a:schemeClr val="tx1"/>
+          </a:fontRef>
+        </p:style>
+      </p:cxnSp>
+      <p:cxnSp>
+        <p:nvCxnSpPr>
+          <p:cNvPr id="7" name="Connector 6"/>
+          <p:cNvCxnSpPr/>
+          <p:nvPr/>
+        </p:nvCxnSpPr>
+        <p:spPr>
+          <a:xfrm>
+            <a:off x="7113361" y="3863181"/>
+            <a:ext cx="346782" cy="0"/>
+          </a:xfrm>
+          <a:prstGeom prst="line">
+            <a:avLst/>
+          </a:prstGeom>
+          <a:ln w="12700">
+            <a:solidFill>
+              <a:srgbClr val="555555"/>
+            </a:solidFill>
+          </a:ln>
+        </p:spPr>
+        <p:style>
+          <a:lnRef idx="2">
+            <a:schemeClr val="accent1"/>
+          </a:lnRef>
+          <a:fillRef idx="0">
+            <a:schemeClr val="accent1"/>
+          </a:fillRef>
+          <a:effectRef idx="1">
+            <a:schemeClr val="accent1"/>
+          </a:effectRef>
+          <a:fontRef idx="minor">
+            <a:schemeClr val="tx1"/>
+          </a:fontRef>
+        </p:style>
+      </p:cxnSp>
+      <p:sp>
+        <p:nvSpPr>
+          <p:cNvPr id="8" name="Rounded Rectangle 7"/>
+          <p:cNvSpPr/>
+          <p:nvPr/>
+        </p:nvSpPr>
+        <p:spPr>
+          <a:xfrm>
+            <a:off x="4983135" y="2867469"/>
+            <a:ext cx="891722" cy="1991424"/>
+          </a:xfrm>
+          <a:prstGeom prst="roundRect">
+            <a:avLst/>
+          </a:prstGeom>
+          <a:solidFill>
+            <a:srgbClr val="F2F6FC"/>
+          </a:solidFill>
+          <a:ln w="12700">
+            <a:solidFill>
+              <a:srgbClr val="2F5599"/>
+            </a:solidFill>
+          </a:ln>
+        </p:spPr>
+        <p:style>
+          <a:lnRef idx="1">
+            <a:schemeClr val="accent1"/>
+          </a:lnRef>
+          <a:fillRef idx="3">
+            <a:schemeClr val="accent1"/>
+          </a:fillRef>
+          <a:effectRef idx="2">
+            <a:schemeClr val="accent1"/>
+          </a:effectRef>
+          <a:fontRef idx="minor">
+            <a:schemeClr val="lt1"/>
+          </a:fontRef>
+        </p:style>
+        <p:txBody>
+          <a:bodyPr rtlCol="0" anchor="ctr" lIns="50000" rIns="50000" tIns="50000" bIns="50000" wrap="square">
+            <a:noAutofit/>
+          </a:bodyPr>
+          <a:lstStyle/>
+          <a:p>
+            <a:pPr algn="ctr"/>
+            <a:r>
+              <a:rPr sz="1000" b="1">
+                <a:solidFill>
+                  <a:srgbClr val="202020"/>
+                </a:solidFill>
+              </a:rPr>
+              <a:t>Top-k 路由</a:t>
+            </a:r>
+          </a:p>
+        </p:txBody>
+      </p:sp>
+      <p:sp>
+        <p:nvSpPr>
+          <p:cNvPr id="9" name="Rounded Rectangle 8"/>
+          <p:cNvSpPr/>
+          <p:nvPr/>
+        </p:nvSpPr>
+        <p:spPr>
+          <a:xfrm>
+            <a:off x="6221639" y="2867469"/>
+            <a:ext cx="891722" cy="1991424"/>
+          </a:xfrm>
+          <a:prstGeom prst="roundRect">
+            <a:avLst/>
+          </a:prstGeom>
+          <a:solidFill>
+            <a:srgbClr val="F2F6FC"/>
+          </a:solidFill>
+          <a:ln w="12700">
+            <a:solidFill>
+              <a:srgbClr val="2F5599"/>
+            </a:solidFill>
+          </a:ln>
+        </p:spPr>
+        <p:style>
+          <a:lnRef idx="1">
+            <a:schemeClr val="accent1"/>
+          </a:lnRef>
+          <a:fillRef idx="3">
+            <a:schemeClr val="accent1"/>
+          </a:fillRef>
+          <a:effectRef idx="2">
+            <a:schemeClr val="accent1"/>
+          </a:effectRef>
+          <a:fontRef idx="minor">
+            <a:schemeClr val="lt1"/>
+          </a:fontRef>
+        </p:style>
+        <p:txBody>
+          <a:bodyPr rtlCol="0" anchor="ctr" lIns="50000" rIns="50000" tIns="50000" bIns="50000" wrap="square">
+            <a:noAutofit/>
+          </a:bodyPr>
+          <a:lstStyle/>
+          <a:p>
+            <a:pPr algn="ctr"/>
+            <a:r>
+              <a:rPr sz="1000" b="1">
+                <a:solidFill>
+                  <a:srgbClr val="202020"/>
+                </a:solidFill>
+              </a:rPr>
+              <a:t>低秩估计</a:t>
+            </a:r>
+          </a:p>
+        </p:txBody>
+      </p:sp>
+      <p:sp>
+        <p:nvSpPr>
+          <p:cNvPr id="10" name="Rounded Rectangle 9"/>
+          <p:cNvSpPr/>
+          <p:nvPr/>
+        </p:nvSpPr>
+        <p:spPr>
+          <a:xfrm>
+            <a:off x="7460143" y="2867469"/>
+            <a:ext cx="891722" cy="1991424"/>
+          </a:xfrm>
+          <a:prstGeom prst="roundRect">
+            <a:avLst/>
+          </a:prstGeom>
+          <a:solidFill>
+            <a:srgbClr val="F2F6FC"/>
+          </a:solidFill>
+          <a:ln w="12700">
+            <a:solidFill>
+              <a:srgbClr val="2F5599"/>
+            </a:solidFill>
+          </a:ln>
+        </p:spPr>
+        <p:style>
+          <a:lnRef idx="1">
+            <a:schemeClr val="accent1"/>
+          </a:lnRef>
+          <a:fillRef idx="3">
+            <a:schemeClr val="accent1"/>
+          </a:fillRef>
+          <a:effectRef idx="2">
+            <a:schemeClr val="accent1"/>
+          </a:effectRef>
+          <a:fontRef idx="minor">
+            <a:schemeClr val="lt1"/>
+          </a:fontRef>
+        </p:style>
+        <p:txBody>
+          <a:bodyPr rtlCol="0" anchor="ctr" lIns="50000" rIns="50000" tIns="50000" bIns="50000" wrap="square">
+            <a:noAutofit/>
+          </a:bodyPr>
+          <a:lstStyle/>
+          <a:p>
+            <a:pPr algn="ctr"/>
+            <a:r>
+              <a:rPr sz="1000" b="1">
+                <a:solidFill>
+                  <a:srgbClr val="202020"/>
+                </a:solidFill>
+              </a:rPr>
+              <a:t>KV 协同</a:t>
+            </a:r>
+          </a:p>
+        </p:txBody>
+      </p:sp>
     </p:spTree>
   </p:cSld>
   <p:clrMapOvr>
@@ -3404,12 +3620,7 @@
           <a:lstStyle/>
           <a:p>
             <a:r>
-              <a:rPr b="1">
-                <a:solidFill>
-                  <a:srgbClr val="1F4E79"/>
-                </a:solidFill>
-                <a:latin typeface="Source Han Sans CN"/>
-              </a:rPr>
+              <a:rPr b="1"/>
               <a:t>Architecture</a:t>
             </a:r>
           </a:p>
@@ -3444,30 +3655,374 @@
           <a:p/>
         </p:txBody>
       </p:sp>
-      <p:pic>
-        <p:nvPicPr>
-          <p:cNvPr id="5" name="Picture 4" descr="mermaid-4d547d85e293.png"/>
-          <p:cNvPicPr>
-            <a:picLocks noChangeAspect="1"/>
-          </p:cNvPicPr>
+      <p:sp>
+        <p:nvSpPr>
+          <p:cNvPr id="5" name="Rectangle 4"/>
+          <p:cNvSpPr/>
           <p:nvPr/>
-        </p:nvPicPr>
-        <p:blipFill>
-          <a:blip r:embed="rId2"/>
-          <a:stretch>
-            <a:fillRect/>
-          </a:stretch>
-        </p:blipFill>
+        </p:nvSpPr>
         <p:spPr>
           <a:xfrm>
-            <a:off x="457200" y="1463040"/>
-            <a:ext cx="2393044" cy="4937760"/>
+            <a:off x="1792288" y="612775"/>
+            <a:ext cx="5486400" cy="4114800"/>
           </a:xfrm>
           <a:prstGeom prst="rect">
             <a:avLst/>
           </a:prstGeom>
+          <a:solidFill>
+            <a:srgbClr val="FFFFFF"/>
+          </a:solidFill>
+          <a:ln>
+            <a:noFill/>
+          </a:ln>
         </p:spPr>
-      </p:pic>
+        <p:style>
+          <a:lnRef idx="1">
+            <a:schemeClr val="accent1"/>
+          </a:lnRef>
+          <a:fillRef idx="3">
+            <a:schemeClr val="accent1"/>
+          </a:fillRef>
+          <a:effectRef idx="2">
+            <a:schemeClr val="accent1"/>
+          </a:effectRef>
+          <a:fontRef idx="minor">
+            <a:schemeClr val="lt1"/>
+          </a:fontRef>
+        </p:style>
+        <p:txBody>
+          <a:bodyPr rtlCol="0" anchor="ctr"/>
+          <a:lstStyle/>
+          <a:p>
+            <a:pPr algn="ctr"/>
+          </a:p>
+        </p:txBody>
+      </p:sp>
+      <p:cxnSp>
+        <p:nvCxnSpPr>
+          <p:cNvPr id="6" name="Connector 5"/>
+          <p:cNvCxnSpPr/>
+          <p:nvPr/>
+        </p:nvCxnSpPr>
+        <p:spPr>
+          <a:xfrm>
+            <a:off x="3096953" y="2670175"/>
+            <a:ext cx="353325" cy="0"/>
+          </a:xfrm>
+          <a:prstGeom prst="line">
+            <a:avLst/>
+          </a:prstGeom>
+          <a:ln w="12700">
+            <a:solidFill>
+              <a:srgbClr val="555555"/>
+            </a:solidFill>
+          </a:ln>
+        </p:spPr>
+        <p:style>
+          <a:lnRef idx="2">
+            <a:schemeClr val="accent1"/>
+          </a:lnRef>
+          <a:fillRef idx="0">
+            <a:schemeClr val="accent1"/>
+          </a:fillRef>
+          <a:effectRef idx="1">
+            <a:schemeClr val="accent1"/>
+          </a:effectRef>
+          <a:fontRef idx="minor">
+            <a:schemeClr val="tx1"/>
+          </a:fontRef>
+        </p:style>
+      </p:cxnSp>
+      <p:cxnSp>
+        <p:nvCxnSpPr>
+          <p:cNvPr id="7" name="Connector 6"/>
+          <p:cNvCxnSpPr/>
+          <p:nvPr/>
+        </p:nvCxnSpPr>
+        <p:spPr>
+          <a:xfrm>
+            <a:off x="4358825" y="2670175"/>
+            <a:ext cx="353325" cy="0"/>
+          </a:xfrm>
+          <a:prstGeom prst="line">
+            <a:avLst/>
+          </a:prstGeom>
+          <a:ln w="12700">
+            <a:solidFill>
+              <a:srgbClr val="555555"/>
+            </a:solidFill>
+          </a:ln>
+        </p:spPr>
+        <p:style>
+          <a:lnRef idx="2">
+            <a:schemeClr val="accent1"/>
+          </a:lnRef>
+          <a:fillRef idx="0">
+            <a:schemeClr val="accent1"/>
+          </a:fillRef>
+          <a:effectRef idx="1">
+            <a:schemeClr val="accent1"/>
+          </a:effectRef>
+          <a:fontRef idx="minor">
+            <a:schemeClr val="tx1"/>
+          </a:fontRef>
+        </p:style>
+      </p:cxnSp>
+      <p:cxnSp>
+        <p:nvCxnSpPr>
+          <p:cNvPr id="8" name="Connector 7"/>
+          <p:cNvCxnSpPr/>
+          <p:nvPr/>
+        </p:nvCxnSpPr>
+        <p:spPr>
+          <a:xfrm>
+            <a:off x="5620697" y="2670175"/>
+            <a:ext cx="353325" cy="0"/>
+          </a:xfrm>
+          <a:prstGeom prst="line">
+            <a:avLst/>
+          </a:prstGeom>
+          <a:ln w="12700">
+            <a:solidFill>
+              <a:srgbClr val="555555"/>
+            </a:solidFill>
+          </a:ln>
+        </p:spPr>
+        <p:style>
+          <a:lnRef idx="2">
+            <a:schemeClr val="accent1"/>
+          </a:lnRef>
+          <a:fillRef idx="0">
+            <a:schemeClr val="accent1"/>
+          </a:fillRef>
+          <a:effectRef idx="1">
+            <a:schemeClr val="accent1"/>
+          </a:effectRef>
+          <a:fontRef idx="minor">
+            <a:schemeClr val="tx1"/>
+          </a:fontRef>
+        </p:style>
+      </p:cxnSp>
+      <p:sp>
+        <p:nvSpPr>
+          <p:cNvPr id="9" name="Rounded Rectangle 8"/>
+          <p:cNvSpPr/>
+          <p:nvPr/>
+        </p:nvSpPr>
+        <p:spPr>
+          <a:xfrm>
+            <a:off x="2188406" y="1764919"/>
+            <a:ext cx="908547" cy="1810512"/>
+          </a:xfrm>
+          <a:prstGeom prst="roundRect">
+            <a:avLst/>
+          </a:prstGeom>
+          <a:solidFill>
+            <a:srgbClr val="F2F6FC"/>
+          </a:solidFill>
+          <a:ln w="12700">
+            <a:solidFill>
+              <a:srgbClr val="2F5599"/>
+            </a:solidFill>
+          </a:ln>
+        </p:spPr>
+        <p:style>
+          <a:lnRef idx="1">
+            <a:schemeClr val="accent1"/>
+          </a:lnRef>
+          <a:fillRef idx="3">
+            <a:schemeClr val="accent1"/>
+          </a:fillRef>
+          <a:effectRef idx="2">
+            <a:schemeClr val="accent1"/>
+          </a:effectRef>
+          <a:fontRef idx="minor">
+            <a:schemeClr val="lt1"/>
+          </a:fontRef>
+        </p:style>
+        <p:txBody>
+          <a:bodyPr rtlCol="0" anchor="ctr" lIns="50000" rIns="50000" tIns="50000" bIns="50000" wrap="square">
+            <a:noAutofit/>
+          </a:bodyPr>
+          <a:lstStyle/>
+          <a:p>
+            <a:pPr algn="ctr"/>
+            <a:r>
+              <a:rPr sz="1000" b="1">
+                <a:solidFill>
+                  <a:srgbClr val="202020"/>
+                </a:solidFill>
+              </a:rPr>
+              <a:t>Token序列</a:t>
+            </a:r>
+          </a:p>
+        </p:txBody>
+      </p:sp>
+      <p:sp>
+        <p:nvSpPr>
+          <p:cNvPr id="10" name="Rounded Rectangle 9"/>
+          <p:cNvSpPr/>
+          <p:nvPr/>
+        </p:nvSpPr>
+        <p:spPr>
+          <a:xfrm>
+            <a:off x="3450278" y="1764919"/>
+            <a:ext cx="908547" cy="1810512"/>
+          </a:xfrm>
+          <a:prstGeom prst="roundRect">
+            <a:avLst/>
+          </a:prstGeom>
+          <a:solidFill>
+            <a:srgbClr val="F2F6FC"/>
+          </a:solidFill>
+          <a:ln w="12700">
+            <a:solidFill>
+              <a:srgbClr val="2F5599"/>
+            </a:solidFill>
+          </a:ln>
+        </p:spPr>
+        <p:style>
+          <a:lnRef idx="1">
+            <a:schemeClr val="accent1"/>
+          </a:lnRef>
+          <a:fillRef idx="3">
+            <a:schemeClr val="accent1"/>
+          </a:fillRef>
+          <a:effectRef idx="2">
+            <a:schemeClr val="accent1"/>
+          </a:effectRef>
+          <a:fontRef idx="minor">
+            <a:schemeClr val="lt1"/>
+          </a:fontRef>
+        </p:style>
+        <p:txBody>
+          <a:bodyPr rtlCol="0" anchor="ctr" lIns="50000" rIns="50000" tIns="50000" bIns="50000" wrap="square">
+            <a:noAutofit/>
+          </a:bodyPr>
+          <a:lstStyle/>
+          <a:p>
+            <a:pPr algn="ctr"/>
+            <a:r>
+              <a:rPr sz="1000" b="1">
+                <a:solidFill>
+                  <a:srgbClr val="202020"/>
+                </a:solidFill>
+              </a:rPr>
+              <a:t>动态路由</a:t>
+            </a:r>
+          </a:p>
+        </p:txBody>
+      </p:sp>
+      <p:sp>
+        <p:nvSpPr>
+          <p:cNvPr id="11" name="Rounded Rectangle 10"/>
+          <p:cNvSpPr/>
+          <p:nvPr/>
+        </p:nvSpPr>
+        <p:spPr>
+          <a:xfrm>
+            <a:off x="4712150" y="1764919"/>
+            <a:ext cx="908547" cy="1810512"/>
+          </a:xfrm>
+          <a:prstGeom prst="roundRect">
+            <a:avLst/>
+          </a:prstGeom>
+          <a:solidFill>
+            <a:srgbClr val="F2F6FC"/>
+          </a:solidFill>
+          <a:ln w="12700">
+            <a:solidFill>
+              <a:srgbClr val="2F5599"/>
+            </a:solidFill>
+          </a:ln>
+        </p:spPr>
+        <p:style>
+          <a:lnRef idx="1">
+            <a:schemeClr val="accent1"/>
+          </a:lnRef>
+          <a:fillRef idx="3">
+            <a:schemeClr val="accent1"/>
+          </a:fillRef>
+          <a:effectRef idx="2">
+            <a:schemeClr val="accent1"/>
+          </a:effectRef>
+          <a:fontRef idx="minor">
+            <a:schemeClr val="lt1"/>
+          </a:fontRef>
+        </p:style>
+        <p:txBody>
+          <a:bodyPr rtlCol="0" anchor="ctr" lIns="50000" rIns="50000" tIns="50000" bIns="50000" wrap="square">
+            <a:noAutofit/>
+          </a:bodyPr>
+          <a:lstStyle/>
+          <a:p>
+            <a:pPr algn="ctr"/>
+            <a:r>
+              <a:rPr sz="1000" b="1">
+                <a:solidFill>
+                  <a:srgbClr val="202020"/>
+                </a:solidFill>
+              </a:rPr>
+              <a:t>稀疏注意力</a:t>
+            </a:r>
+          </a:p>
+        </p:txBody>
+      </p:sp>
+      <p:sp>
+        <p:nvSpPr>
+          <p:cNvPr id="12" name="Rounded Rectangle 11"/>
+          <p:cNvSpPr/>
+          <p:nvPr/>
+        </p:nvSpPr>
+        <p:spPr>
+          <a:xfrm>
+            <a:off x="5974022" y="1764919"/>
+            <a:ext cx="908547" cy="1810512"/>
+          </a:xfrm>
+          <a:prstGeom prst="roundRect">
+            <a:avLst/>
+          </a:prstGeom>
+          <a:solidFill>
+            <a:srgbClr val="F2F6FC"/>
+          </a:solidFill>
+          <a:ln w="12700">
+            <a:solidFill>
+              <a:srgbClr val="2F5599"/>
+            </a:solidFill>
+          </a:ln>
+        </p:spPr>
+        <p:style>
+          <a:lnRef idx="1">
+            <a:schemeClr val="accent1"/>
+          </a:lnRef>
+          <a:fillRef idx="3">
+            <a:schemeClr val="accent1"/>
+          </a:fillRef>
+          <a:effectRef idx="2">
+            <a:schemeClr val="accent1"/>
+          </a:effectRef>
+          <a:fontRef idx="minor">
+            <a:schemeClr val="lt1"/>
+          </a:fontRef>
+        </p:style>
+        <p:txBody>
+          <a:bodyPr rtlCol="0" anchor="ctr" lIns="50000" rIns="50000" tIns="50000" bIns="50000" wrap="square">
+            <a:noAutofit/>
+          </a:bodyPr>
+          <a:lstStyle/>
+          <a:p>
+            <a:pPr algn="ctr"/>
+            <a:r>
+              <a:rPr sz="1000" b="1">
+                <a:solidFill>
+                  <a:srgbClr val="202020"/>
+                </a:solidFill>
+              </a:rPr>
+              <a:t>上下文输出</a:t>
+            </a:r>
+          </a:p>
+        </p:txBody>
+      </p:sp>
     </p:spTree>
   </p:cSld>
   <p:clrMapOvr>
@@ -3502,12 +4057,7 @@
           <a:lstStyle/>
           <a:p>
             <a:r>
-              <a:rPr b="1">
-                <a:solidFill>
-                  <a:srgbClr val="1F4E79"/>
-                </a:solidFill>
-                <a:latin typeface="Source Han Sans CN"/>
-              </a:rPr>
+              <a:rPr b="1"/>
               <a:t>Experimental Setup</a:t>
             </a:r>
           </a:p>
@@ -3530,36 +4080,24 @@
           <a:p>
             <a:pPr/>
             <a:r>
-              <a:rPr>
-                <a:latin typeface="Source Han Sans CN"/>
-              </a:rPr>
               <a:t>**Datasets**: PG-19, LongBench, ZeroSCROLLS</a:t>
             </a:r>
           </a:p>
           <a:p>
             <a:pPr/>
             <a:r>
-              <a:rPr>
-                <a:latin typeface="Source Han Sans CN"/>
-              </a:rPr>
               <a:t>**Backbones**: LLaMA-2-7B, Mistral-7B</a:t>
             </a:r>
           </a:p>
           <a:p>
             <a:pPr/>
             <a:r>
-              <a:rPr>
-                <a:latin typeface="Source Han Sans CN"/>
-              </a:rPr>
               <a:t>**Baselines**: Full Attention, Longformer, BigBird, StreamingLLM</a:t>
             </a:r>
           </a:p>
           <a:p>
             <a:pPr/>
             <a:r>
-              <a:rPr>
-                <a:latin typeface="Source Han Sans CN"/>
-              </a:rPr>
               <a:t>**Hardware**: 8 × A100 80GB</a:t>
             </a:r>
           </a:p>
@@ -3599,12 +4137,7 @@
           <a:lstStyle/>
           <a:p>
             <a:r>
-              <a:rPr b="1">
-                <a:solidFill>
-                  <a:srgbClr val="1F4E79"/>
-                </a:solidFill>
-                <a:latin typeface="Source Han Sans CN"/>
-              </a:rPr>
+              <a:rPr b="1"/>
               <a:t>Results</a:t>
             </a:r>
           </a:p>
@@ -3636,7 +4169,7 @@
           <p:nvPr/>
         </p:nvGraphicFramePr>
         <p:xfrm>
-          <a:off x="457200" y="1463040"/>
+          <a:off x="457200" y="1600200"/>
           <a:ext cx="8229600" cy="2194560"/>
         </p:xfrm>
         <a:graphic>
@@ -3993,12 +4526,7 @@
           <a:lstStyle/>
           <a:p>
             <a:r>
-              <a:rPr b="1">
-                <a:solidFill>
-                  <a:srgbClr val="1F4E79"/>
-                </a:solidFill>
-                <a:latin typeface="Source Han Sans CN"/>
-              </a:rPr>
+              <a:rPr b="1"/>
               <a:t>Conclusion</a:t>
             </a:r>
           </a:p>
@@ -4021,27 +4549,18 @@
           <a:p>
             <a:pPr/>
             <a:r>
-              <a:rPr>
-                <a:latin typeface="Source Han Sans CN"/>
-              </a:rPr>
               <a:t>DRSA 在 5 个长文本任务上同时改善精度与效率</a:t>
             </a:r>
           </a:p>
           <a:p>
             <a:pPr/>
             <a:r>
-              <a:rPr>
-                <a:latin typeface="Source Han Sans CN"/>
-              </a:rPr>
               <a:t>与现有 KV-Cache 优化方法正交，可叠加使用</a:t>
             </a:r>
           </a:p>
           <a:p>
             <a:pPr/>
             <a:r>
-              <a:rPr>
-                <a:latin typeface="Source Han Sans CN"/>
-              </a:rPr>
               <a:t>代码与权重将开源于 GitHub</a:t>
             </a:r>
           </a:p>

</xml_diff>